<commit_message>
Simplify and correct ERD explanation
</commit_message>
<xml_diff>
--- a/docs/architecture/GlobalPay_Mandatory_Architecture_Deliverables.pptx
+++ b/docs/architecture/GlobalPay_Mandatory_Architecture_Deliverables.pptx
@@ -14680,7 +14680,7 @@
 </file>
 
 <file path=ppt/slides/slide17.xml><?xml version="1.0" encoding="utf-8"?>
-<p:sld xmlns:a="http://schemas.openxmlformats.org/drawingml/2006/main" xmlns:r="http://schemas.openxmlformats.org/officeDocument/2006/relationships" xmlns:p="http://schemas.openxmlformats.org/presentationml/2006/main">
+<p:sld xmlns:a="http://schemas.openxmlformats.org/drawingml/2006/main" xmlns:p="http://schemas.openxmlformats.org/presentationml/2006/main">
   <p:cSld name="Slide 17">
     <p:bg>
       <p:bgPr>
@@ -17191,256 +17191,6 @@
       </p:sp>
       <p:sp>
         <p:nvSpPr>
-          <p:cNvPr id="65" name="Shape 63"/>
-          <p:cNvSpPr/>
-          <p:nvPr/>
-        </p:nvSpPr>
-        <p:spPr>
-          <a:xfrm>
-            <a:off x="1965960" y="1389888"/>
-            <a:ext cx="91440" cy="9144"/>
-          </a:xfrm>
-          <a:prstGeom prst="line">
-            <a:avLst/>
-          </a:prstGeom>
-          <a:noFill/>
-          <a:ln w="17780">
-            <a:solidFill>
-              <a:srgbClr val="666666"/>
-            </a:solidFill>
-            <a:prstDash val="solid"/>
-            <a:headEnd type="none"/>
-            <a:tailEnd type="triangle"/>
-          </a:ln>
-        </p:spPr>
-      </p:sp>
-      <p:sp>
-        <p:nvSpPr>
-          <p:cNvPr id="66" name="Shape 64"/>
-          <p:cNvSpPr/>
-          <p:nvPr/>
-        </p:nvSpPr>
-        <p:spPr>
-          <a:xfrm>
-            <a:off x="3749040" y="1389888"/>
-            <a:ext cx="91440" cy="9144"/>
-          </a:xfrm>
-          <a:prstGeom prst="line">
-            <a:avLst/>
-          </a:prstGeom>
-          <a:noFill/>
-          <a:ln w="17780">
-            <a:solidFill>
-              <a:srgbClr val="666666"/>
-            </a:solidFill>
-            <a:prstDash val="solid"/>
-            <a:headEnd type="none"/>
-            <a:tailEnd type="triangle"/>
-          </a:ln>
-        </p:spPr>
-      </p:sp>
-      <p:sp>
-        <p:nvSpPr>
-          <p:cNvPr id="67" name="Shape 65"/>
-          <p:cNvSpPr/>
-          <p:nvPr/>
-        </p:nvSpPr>
-        <p:spPr>
-          <a:xfrm>
-            <a:off x="5532120" y="1389888"/>
-            <a:ext cx="91440" cy="9144"/>
-          </a:xfrm>
-          <a:prstGeom prst="line">
-            <a:avLst/>
-          </a:prstGeom>
-          <a:noFill/>
-          <a:ln w="17780">
-            <a:solidFill>
-              <a:srgbClr val="666666"/>
-            </a:solidFill>
-            <a:prstDash val="solid"/>
-            <a:headEnd type="none"/>
-            <a:tailEnd type="triangle"/>
-          </a:ln>
-        </p:spPr>
-      </p:sp>
-      <p:sp>
-        <p:nvSpPr>
-          <p:cNvPr id="68" name="Shape 66"/>
-          <p:cNvSpPr/>
-          <p:nvPr/>
-        </p:nvSpPr>
-        <p:spPr>
-          <a:xfrm>
-            <a:off x="2903220" y="1828800"/>
-            <a:ext cx="9144" cy="182880"/>
-          </a:xfrm>
-          <a:prstGeom prst="line">
-            <a:avLst/>
-          </a:prstGeom>
-          <a:noFill/>
-          <a:ln w="17780">
-            <a:solidFill>
-              <a:srgbClr val="666666"/>
-            </a:solidFill>
-            <a:prstDash val="solid"/>
-            <a:headEnd type="none"/>
-            <a:tailEnd type="triangle"/>
-          </a:ln>
-        </p:spPr>
-      </p:sp>
-      <p:sp>
-        <p:nvSpPr>
-          <p:cNvPr id="69" name="Shape 67"/>
-          <p:cNvSpPr/>
-          <p:nvPr/>
-        </p:nvSpPr>
-        <p:spPr>
-          <a:xfrm>
-            <a:off x="1965960" y="2487168"/>
-            <a:ext cx="91440" cy="9144"/>
-          </a:xfrm>
-          <a:prstGeom prst="line">
-            <a:avLst/>
-          </a:prstGeom>
-          <a:noFill/>
-          <a:ln w="17780">
-            <a:solidFill>
-              <a:srgbClr val="666666"/>
-            </a:solidFill>
-            <a:prstDash val="solid"/>
-            <a:headEnd type="none"/>
-            <a:tailEnd type="triangle"/>
-          </a:ln>
-        </p:spPr>
-      </p:sp>
-      <p:sp>
-        <p:nvSpPr>
-          <p:cNvPr id="70" name="Shape 68"/>
-          <p:cNvSpPr/>
-          <p:nvPr/>
-        </p:nvSpPr>
-        <p:spPr>
-          <a:xfrm>
-            <a:off x="3749040" y="2487168"/>
-            <a:ext cx="91440" cy="9144"/>
-          </a:xfrm>
-          <a:prstGeom prst="line">
-            <a:avLst/>
-          </a:prstGeom>
-          <a:noFill/>
-          <a:ln w="17780">
-            <a:solidFill>
-              <a:srgbClr val="666666"/>
-            </a:solidFill>
-            <a:prstDash val="solid"/>
-            <a:headEnd type="none"/>
-            <a:tailEnd type="triangle"/>
-          </a:ln>
-        </p:spPr>
-      </p:sp>
-      <p:sp>
-        <p:nvSpPr>
-          <p:cNvPr id="71" name="Shape 69"/>
-          <p:cNvSpPr/>
-          <p:nvPr/>
-        </p:nvSpPr>
-        <p:spPr>
-          <a:xfrm>
-            <a:off x="5532120" y="2487168"/>
-            <a:ext cx="91440" cy="9144"/>
-          </a:xfrm>
-          <a:prstGeom prst="line">
-            <a:avLst/>
-          </a:prstGeom>
-          <a:noFill/>
-          <a:ln w="17780">
-            <a:solidFill>
-              <a:srgbClr val="666666"/>
-            </a:solidFill>
-            <a:prstDash val="solid"/>
-            <a:headEnd type="none"/>
-            <a:tailEnd type="triangle"/>
-          </a:ln>
-        </p:spPr>
-      </p:sp>
-      <p:sp>
-        <p:nvSpPr>
-          <p:cNvPr id="72" name="Shape 70"/>
-          <p:cNvSpPr/>
-          <p:nvPr/>
-        </p:nvSpPr>
-        <p:spPr>
-          <a:xfrm>
-            <a:off x="7315200" y="2487168"/>
-            <a:ext cx="91440" cy="9144"/>
-          </a:xfrm>
-          <a:prstGeom prst="line">
-            <a:avLst/>
-          </a:prstGeom>
-          <a:noFill/>
-          <a:ln w="17780">
-            <a:solidFill>
-              <a:srgbClr val="666666"/>
-            </a:solidFill>
-            <a:prstDash val="solid"/>
-            <a:headEnd type="none"/>
-            <a:tailEnd type="triangle"/>
-          </a:ln>
-        </p:spPr>
-      </p:sp>
-      <p:sp>
-        <p:nvSpPr>
-          <p:cNvPr id="73" name="Shape 71"/>
-          <p:cNvSpPr/>
-          <p:nvPr/>
-        </p:nvSpPr>
-        <p:spPr>
-          <a:xfrm>
-            <a:off x="1120140" y="2926080"/>
-            <a:ext cx="9144" cy="182880"/>
-          </a:xfrm>
-          <a:prstGeom prst="line">
-            <a:avLst/>
-          </a:prstGeom>
-          <a:noFill/>
-          <a:ln w="17780">
-            <a:solidFill>
-              <a:srgbClr val="666666"/>
-            </a:solidFill>
-            <a:prstDash val="solid"/>
-            <a:headEnd type="none"/>
-            <a:tailEnd type="triangle"/>
-          </a:ln>
-        </p:spPr>
-      </p:sp>
-      <p:sp>
-        <p:nvSpPr>
-          <p:cNvPr id="74" name="Shape 72"/>
-          <p:cNvSpPr/>
-          <p:nvPr/>
-        </p:nvSpPr>
-        <p:spPr>
-          <a:xfrm>
-            <a:off x="1965960" y="3520440"/>
-            <a:ext cx="91440" cy="9144"/>
-          </a:xfrm>
-          <a:prstGeom prst="line">
-            <a:avLst/>
-          </a:prstGeom>
-          <a:noFill/>
-          <a:ln w="17780">
-            <a:solidFill>
-              <a:srgbClr val="666666"/>
-            </a:solidFill>
-            <a:prstDash val="solid"/>
-            <a:headEnd type="none"/>
-            <a:tailEnd type="triangle"/>
-          </a:ln>
-        </p:spPr>
-      </p:sp>
-      <p:sp>
-        <p:nvSpPr>
           <p:cNvPr id="75" name="Text 73"/>
           <p:cNvSpPr/>
           <p:nvPr/>
@@ -17472,7 +17222,7 @@
                 <a:ea typeface="Calibri" pitchFamily="34" charset="-122"/>
                 <a:cs typeface="Calibri" pitchFamily="34" charset="-120"/>
               </a:rPr>
-              <a:t>User 1 to 0..1 Customer or Merchant; Customer/Merchant 1 to 0..* Wallets; Customer 1 to 0..* Consents and CBDC Wallets; Transaction 1 to 2..* Ledger Entries and 0..1 Fraud Alert; Fraud Alert 1 to 0..* Investigations. Model Registry and Audit Log are cross-cutting.</a:t>
+              <a:t>How to read it: FK means foreign key and identifies the related table. A user may have a customer or merchant profile. Profiles own wallets. Transactions create ledger entries and may trigger fraud alerts for investigation.</a:t>
             </a:r>
             <a:endParaRPr lang="en-US" sz="900" dirty="0"/>
           </a:p>

</xml_diff>

<commit_message>
Correct CBDC architecture reporting flow
</commit_message>
<xml_diff>
--- a/docs/architecture/GlobalPay_Mandatory_Architecture_Deliverables.pptx
+++ b/docs/architecture/GlobalPay_Mandatory_Architecture_Deliverables.pptx
@@ -31719,7 +31719,7 @@
 </file>
 
 <file path=ppt/slides/slide9.xml><?xml version="1.0" encoding="utf-8"?>
-<p:sld xmlns:a="http://schemas.openxmlformats.org/drawingml/2006/main" xmlns:r="http://schemas.openxmlformats.org/officeDocument/2006/relationships" xmlns:p="http://schemas.openxmlformats.org/presentationml/2006/main">
+<p:sld xmlns:a="http://schemas.openxmlformats.org/drawingml/2006/main" xmlns:p="http://schemas.openxmlformats.org/presentationml/2006/main">
   <p:cSld name="Slide 9">
     <p:bg>
       <p:bgPr>
@@ -32219,7 +32219,7 @@
                 <a:ea typeface="Calibri" pitchFamily="34" charset="-122"/>
                 <a:cs typeface="Calibri" pitchFamily="34" charset="-120"/>
               </a:rPr>
-              <a:t>CBDC ledger</a:t>
+              <a:t>CBDC records</a:t>
             </a:r>
             <a:endParaRPr lang="en-US" sz="1050" dirty="0"/>
           </a:p>
@@ -32310,7 +32310,7 @@
                 <a:ea typeface="Calibri" pitchFamily="34" charset="-122"/>
                 <a:cs typeface="Calibri" pitchFamily="34" charset="-120"/>
               </a:rPr>
-              <a:t>Analytics svc</a:t>
+              <a:t>Read-only reporting</a:t>
             </a:r>
             <a:endParaRPr lang="en-US" sz="1050" dirty="0"/>
           </a:p>
@@ -32409,31 +32409,6 @@
       </p:sp>
       <p:sp>
         <p:nvSpPr>
-          <p:cNvPr id="23" name="Shape 21"/>
-          <p:cNvSpPr/>
-          <p:nvPr/>
-        </p:nvSpPr>
-        <p:spPr>
-          <a:xfrm flipH="1">
-            <a:off x="1339596" y="3429000"/>
-            <a:ext cx="6812280" cy="685800"/>
-          </a:xfrm>
-          <a:prstGeom prst="line">
-            <a:avLst/>
-          </a:prstGeom>
-          <a:noFill/>
-          <a:ln w="17780">
-            <a:solidFill>
-              <a:srgbClr val="888888"/>
-            </a:solidFill>
-            <a:prstDash val="dash"/>
-            <a:headEnd type="none"/>
-            <a:tailEnd type="triangle"/>
-          </a:ln>
-        </p:spPr>
-      </p:sp>
-      <p:sp>
-        <p:nvSpPr>
           <p:cNvPr id="24" name="Text 22"/>
           <p:cNvSpPr/>
           <p:nvPr/>
@@ -32465,7 +32440,7 @@
                 <a:ea typeface="Calibri" pitchFamily="34" charset="-122"/>
                 <a:cs typeface="Calibri" pitchFamily="34" charset="-120"/>
               </a:rPr>
-              <a:t>CBDC analytics reports activity; balances remain separate from Module 1 wallets — kept as a separate ledger for audit clarity</a:t>
+              <a:t>Reporting reads cbdc_wallets and cbdc_operations; these records remain separate from commercial wallet data</a:t>
             </a:r>
             <a:endParaRPr lang="en-US" sz="900" dirty="0"/>
           </a:p>

</xml_diff>

<commit_message>
Clarify enterprise network connections
</commit_message>
<xml_diff>
--- a/docs/architecture/GlobalPay_Mandatory_Architecture_Deliverables.pptx
+++ b/docs/architecture/GlobalPay_Mandatory_Architecture_Deliverables.pptx
@@ -6314,7 +6314,7 @@
 </file>
 
 <file path=ppt/slides/slide10.xml><?xml version="1.0" encoding="utf-8"?>
-<p:sld xmlns:a="http://schemas.openxmlformats.org/drawingml/2006/main" xmlns:r="http://schemas.openxmlformats.org/officeDocument/2006/relationships" xmlns:p="http://schemas.openxmlformats.org/presentationml/2006/main">
+<p:sld xmlns:a="http://schemas.openxmlformats.org/drawingml/2006/main" xmlns:p="http://schemas.openxmlformats.org/presentationml/2006/main">
   <p:cSld name="Slide 10">
     <p:bg>
       <p:bgPr>
@@ -7296,7 +7296,7 @@
         <p:spPr>
           <a:xfrm>
             <a:off x="2697480" y="3291840"/>
-            <a:ext cx="9144" cy="137160"/>
+            <a:ext cx="1828800" cy="137160"/>
           </a:xfrm>
           <a:prstGeom prst="line">
             <a:avLst/>
@@ -7319,9 +7319,9 @@
           <p:nvPr/>
         </p:nvSpPr>
         <p:spPr>
-          <a:xfrm>
-            <a:off x="6080760" y="3291840"/>
-            <a:ext cx="9144" cy="137160"/>
+          <a:xfrm flipH="1">
+            <a:off x="4526280" y="3291840"/>
+            <a:ext cx="1554480" cy="137160"/>
           </a:xfrm>
           <a:prstGeom prst="line">
             <a:avLst/>
@@ -7339,14 +7339,39 @@
       </p:sp>
       <p:sp>
         <p:nvSpPr>
+          <p:cNvPr id="41" name="Shape 30 cache connection"/>
+          <p:cNvSpPr/>
+          <p:nvPr/>
+        </p:nvSpPr>
+        <p:spPr>
+          <a:xfrm>
+            <a:off x="6080760" y="3291840"/>
+            <a:ext cx="1554480" cy="137160"/>
+          </a:xfrm>
+          <a:prstGeom prst="line">
+            <a:avLst/>
+          </a:prstGeom>
+          <a:noFill/>
+          <a:ln w="17780">
+            <a:solidFill>
+              <a:srgbClr val="666666"/>
+            </a:solidFill>
+            <a:prstDash val="solid"/>
+            <a:headEnd type="none"/>
+            <a:tailEnd type="triangle"/>
+          </a:ln>
+        </p:spPr>
+      </p:sp>
+      <p:sp>
+        <p:nvSpPr>
           <p:cNvPr id="33" name="Shape 31"/>
           <p:cNvSpPr/>
           <p:nvPr/>
         </p:nvSpPr>
         <p:spPr>
-          <a:xfrm>
-            <a:off x="9464040" y="3291840"/>
-            <a:ext cx="9144" cy="137160"/>
+          <a:xfrm flipH="1">
+            <a:off x="7635240" y="3291840"/>
+            <a:ext cx="1828800" cy="137160"/>
           </a:xfrm>
           <a:prstGeom prst="line">
             <a:avLst/>

</xml_diff>

<commit_message>
Tidy network layout and strengthen DFD connectors
</commit_message>
<xml_diff>
--- a/docs/architecture/GlobalPay_Mandatory_Architecture_Deliverables.pptx
+++ b/docs/architecture/GlobalPay_Mandatory_Architecture_Deliverables.pptx
@@ -6615,7 +6615,7 @@
                 <a:ea typeface="Calibri" pitchFamily="34" charset="-122"/>
                 <a:cs typeface="Calibri" pitchFamily="34" charset="-120"/>
               </a:rPr>
-              <a:t>Browser (examiner)</a:t>
+              <a:t>User web browser</a:t>
             </a:r>
             <a:endParaRPr lang="en-US" sz="1000" dirty="0"/>
           </a:p>
@@ -7296,7 +7296,7 @@
         <p:spPr>
           <a:xfrm>
             <a:off x="2697480" y="3291840"/>
-            <a:ext cx="1828800" cy="137160"/>
+            <a:ext cx="1828800" cy="274320"/>
           </a:xfrm>
           <a:prstGeom prst="line">
             <a:avLst/>
@@ -7321,7 +7321,7 @@
         <p:spPr>
           <a:xfrm flipH="1">
             <a:off x="4526280" y="3291840"/>
-            <a:ext cx="1554480" cy="137160"/>
+            <a:ext cx="1554480" cy="274320"/>
           </a:xfrm>
           <a:prstGeom prst="line">
             <a:avLst/>
@@ -7346,7 +7346,7 @@
         <p:spPr>
           <a:xfrm>
             <a:off x="6080760" y="3291840"/>
-            <a:ext cx="1554480" cy="137160"/>
+            <a:ext cx="1554480" cy="274320"/>
           </a:xfrm>
           <a:prstGeom prst="line">
             <a:avLst/>
@@ -7371,7 +7371,7 @@
         <p:spPr>
           <a:xfrm flipH="1">
             <a:off x="7635240" y="3291840"/>
-            <a:ext cx="1828800" cy="137160"/>
+            <a:ext cx="1828800" cy="274320"/>
           </a:xfrm>
           <a:prstGeom prst="line">
             <a:avLst/>
@@ -7395,7 +7395,7 @@
         </p:nvSpPr>
         <p:spPr>
           <a:xfrm>
-            <a:off x="3154680" y="3429000"/>
+            <a:off x="3154680" y="3566160"/>
             <a:ext cx="2743200" cy="384048"/>
           </a:xfrm>
           <a:prstGeom prst="roundRect">
@@ -7422,7 +7422,7 @@
         </p:nvSpPr>
         <p:spPr>
           <a:xfrm>
-            <a:off x="3209544" y="3456432"/>
+            <a:off x="3209544" y="3593592"/>
             <a:ext cx="2633472" cy="219456"/>
           </a:xfrm>
           <a:prstGeom prst="rect">
@@ -7461,7 +7461,7 @@
         </p:nvSpPr>
         <p:spPr>
           <a:xfrm>
-            <a:off x="3209544" y="3694176"/>
+            <a:off x="3209544" y="3831336"/>
             <a:ext cx="2633472" cy="164592"/>
           </a:xfrm>
           <a:prstGeom prst="rect">
@@ -7500,7 +7500,7 @@
         </p:nvSpPr>
         <p:spPr>
           <a:xfrm>
-            <a:off x="6263640" y="3429000"/>
+            <a:off x="6263640" y="3566160"/>
             <a:ext cx="2743200" cy="384048"/>
           </a:xfrm>
           <a:prstGeom prst="roundRect">
@@ -7527,7 +7527,7 @@
         </p:nvSpPr>
         <p:spPr>
           <a:xfrm>
-            <a:off x="6318504" y="3456432"/>
+            <a:off x="6318504" y="3593592"/>
             <a:ext cx="2633472" cy="219456"/>
           </a:xfrm>
           <a:prstGeom prst="rect">
@@ -7566,7 +7566,7 @@
         </p:nvSpPr>
         <p:spPr>
           <a:xfrm>
-            <a:off x="6318504" y="3694176"/>
+            <a:off x="6318504" y="3831336"/>
             <a:ext cx="2633472" cy="164592"/>
           </a:xfrm>
           <a:prstGeom prst="rect">
@@ -7605,7 +7605,7 @@
         </p:nvSpPr>
         <p:spPr>
           <a:xfrm>
-            <a:off x="8823960" y="3931920"/>
+            <a:off x="8823960" y="3977640"/>
             <a:ext cx="2194560" cy="201168"/>
           </a:xfrm>
           <a:prstGeom prst="roundRect">
@@ -7632,7 +7632,7 @@
         </p:nvSpPr>
         <p:spPr>
           <a:xfrm>
-            <a:off x="8878824" y="3931920"/>
+            <a:off x="8878824" y="3977640"/>
             <a:ext cx="2084832" cy="201168"/>
           </a:xfrm>
           <a:prstGeom prst="rect">
@@ -8716,7 +8716,7 @@
 </file>
 
 <file path=ppt/slides/slide12.xml><?xml version="1.0" encoding="utf-8"?>
-<p:sld xmlns:a="http://schemas.openxmlformats.org/drawingml/2006/main" xmlns:r="http://schemas.openxmlformats.org/officeDocument/2006/relationships" xmlns:p="http://schemas.openxmlformats.org/presentationml/2006/main">
+<p:sld xmlns:a="http://schemas.openxmlformats.org/drawingml/2006/main" xmlns:p="http://schemas.openxmlformats.org/presentationml/2006/main">
   <p:cSld name="Slide 12">
     <p:bg>
       <p:bgPr>
@@ -9451,13 +9451,13 @@
             <a:avLst/>
           </a:prstGeom>
           <a:noFill/>
-          <a:ln w="17780">
+          <a:ln w="25400">
             <a:solidFill>
-              <a:srgbClr val="666666"/>
+              <a:srgbClr val="4B5563"/>
             </a:solidFill>
             <a:prstDash val="solid"/>
-            <a:headEnd type="triangle"/>
-            <a:tailEnd type="triangle"/>
+            <a:headEnd type="triangle" w="lg" len="lg"/>
+            <a:tailEnd type="triangle" w="lg" len="lg"/>
           </a:ln>
         </p:spPr>
       </p:sp>
@@ -9476,13 +9476,13 @@
             <a:avLst/>
           </a:prstGeom>
           <a:noFill/>
-          <a:ln w="17780">
+          <a:ln w="25400">
             <a:solidFill>
-              <a:srgbClr val="666666"/>
+              <a:srgbClr val="4B5563"/>
             </a:solidFill>
             <a:prstDash val="solid"/>
-            <a:headEnd type="triangle"/>
-            <a:tailEnd type="triangle"/>
+            <a:headEnd type="triangle" w="lg" len="lg"/>
+            <a:tailEnd type="triangle" w="lg" len="lg"/>
           </a:ln>
         </p:spPr>
       </p:sp>
@@ -9501,13 +9501,13 @@
             <a:avLst/>
           </a:prstGeom>
           <a:noFill/>
-          <a:ln w="17780">
+          <a:ln w="25400">
             <a:solidFill>
-              <a:srgbClr val="666666"/>
+              <a:srgbClr val="4B5563"/>
             </a:solidFill>
             <a:prstDash val="solid"/>
-            <a:headEnd type="triangle"/>
-            <a:tailEnd type="triangle"/>
+            <a:headEnd type="triangle" w="lg" len="lg"/>
+            <a:tailEnd type="triangle" w="lg" len="lg"/>
           </a:ln>
         </p:spPr>
       </p:sp>
@@ -9526,13 +9526,13 @@
             <a:avLst/>
           </a:prstGeom>
           <a:noFill/>
-          <a:ln w="17780">
+          <a:ln w="25400">
             <a:solidFill>
-              <a:srgbClr val="666666"/>
+              <a:srgbClr val="4B5563"/>
             </a:solidFill>
             <a:prstDash val="solid"/>
-            <a:headEnd type="triangle"/>
-            <a:tailEnd type="triangle"/>
+            <a:headEnd type="triangle" w="lg" len="lg"/>
+            <a:tailEnd type="triangle" w="lg" len="lg"/>
           </a:ln>
         </p:spPr>
       </p:sp>
@@ -9551,13 +9551,13 @@
             <a:avLst/>
           </a:prstGeom>
           <a:noFill/>
-          <a:ln w="17780">
+          <a:ln w="25400">
             <a:solidFill>
-              <a:srgbClr val="666666"/>
+              <a:srgbClr val="4B5563"/>
             </a:solidFill>
             <a:prstDash val="solid"/>
-            <a:headEnd type="triangle"/>
-            <a:tailEnd type="triangle"/>
+            <a:headEnd type="triangle" w="lg" len="lg"/>
+            <a:tailEnd type="triangle" w="lg" len="lg"/>
           </a:ln>
         </p:spPr>
       </p:sp>
@@ -9765,7 +9765,7 @@
 </file>
 
 <file path=ppt/slides/slide13.xml><?xml version="1.0" encoding="utf-8"?>
-<p:sld xmlns:a="http://schemas.openxmlformats.org/drawingml/2006/main" xmlns:r="http://schemas.openxmlformats.org/officeDocument/2006/relationships" xmlns:p="http://schemas.openxmlformats.org/presentationml/2006/main">
+<p:sld xmlns:a="http://schemas.openxmlformats.org/drawingml/2006/main" xmlns:p="http://schemas.openxmlformats.org/presentationml/2006/main">
   <p:cSld name="Slide 13">
     <p:bg>
       <p:bgPr>
@@ -10524,13 +10524,13 @@
             <a:avLst/>
           </a:prstGeom>
           <a:noFill/>
-          <a:ln w="17780">
+          <a:ln w="25400">
             <a:solidFill>
-              <a:srgbClr val="888888"/>
+              <a:srgbClr val="596273"/>
             </a:solidFill>
             <a:prstDash val="solid"/>
             <a:headEnd type="none"/>
-            <a:tailEnd type="triangle"/>
+            <a:tailEnd type="triangle" w="lg" len="lg"/>
           </a:ln>
         </p:spPr>
       </p:sp>
@@ -10630,13 +10630,13 @@
             <a:avLst/>
           </a:prstGeom>
           <a:noFill/>
-          <a:ln w="17780">
+          <a:ln w="25400">
             <a:solidFill>
-              <a:srgbClr val="888888"/>
+              <a:srgbClr val="596273"/>
             </a:solidFill>
             <a:prstDash val="solid"/>
             <a:headEnd type="none"/>
-            <a:tailEnd type="triangle"/>
+            <a:tailEnd type="triangle" w="lg" len="lg"/>
           </a:ln>
         </p:spPr>
       </p:sp>
@@ -10736,13 +10736,13 @@
             <a:avLst/>
           </a:prstGeom>
           <a:noFill/>
-          <a:ln w="17780">
+          <a:ln w="25400">
             <a:solidFill>
-              <a:srgbClr val="888888"/>
+              <a:srgbClr val="596273"/>
             </a:solidFill>
             <a:prstDash val="solid"/>
             <a:headEnd type="none"/>
-            <a:tailEnd type="triangle"/>
+            <a:tailEnd type="triangle" w="lg" len="lg"/>
           </a:ln>
         </p:spPr>
       </p:sp>
@@ -10842,13 +10842,13 @@
             <a:avLst/>
           </a:prstGeom>
           <a:noFill/>
-          <a:ln w="17780">
+          <a:ln w="25400">
             <a:solidFill>
-              <a:srgbClr val="888888"/>
+              <a:srgbClr val="596273"/>
             </a:solidFill>
             <a:prstDash val="solid"/>
             <a:headEnd type="none"/>
-            <a:tailEnd type="triangle"/>
+            <a:tailEnd type="triangle" w="lg" len="lg"/>
           </a:ln>
         </p:spPr>
       </p:sp>
@@ -10948,13 +10948,13 @@
             <a:avLst/>
           </a:prstGeom>
           <a:noFill/>
-          <a:ln w="17780">
+          <a:ln w="25400">
             <a:solidFill>
-              <a:srgbClr val="888888"/>
+              <a:srgbClr val="596273"/>
             </a:solidFill>
             <a:prstDash val="solid"/>
             <a:headEnd type="none"/>
-            <a:tailEnd type="triangle"/>
+            <a:tailEnd type="triangle" w="lg" len="lg"/>
           </a:ln>
         </p:spPr>
       </p:sp>
@@ -11039,13 +11039,13 @@
             <a:avLst/>
           </a:prstGeom>
           <a:noFill/>
-          <a:ln w="17780">
+          <a:ln w="25400">
             <a:solidFill>
-              <a:srgbClr val="888888"/>
+              <a:srgbClr val="596273"/>
             </a:solidFill>
             <a:prstDash val="solid"/>
             <a:headEnd type="none"/>
-            <a:tailEnd type="triangle"/>
+            <a:tailEnd type="triangle" w="lg" len="lg"/>
           </a:ln>
         </p:spPr>
       </p:sp>
@@ -11130,13 +11130,13 @@
             <a:avLst/>
           </a:prstGeom>
           <a:noFill/>
-          <a:ln w="17780">
+          <a:ln w="25400">
             <a:solidFill>
-              <a:srgbClr val="888888"/>
+              <a:srgbClr val="596273"/>
             </a:solidFill>
             <a:prstDash val="solid"/>
             <a:headEnd type="none"/>
-            <a:tailEnd type="triangle"/>
+            <a:tailEnd type="triangle" w="lg" len="lg"/>
           </a:ln>
         </p:spPr>
       </p:sp>
@@ -11155,13 +11155,13 @@
             <a:avLst/>
           </a:prstGeom>
           <a:noFill/>
-          <a:ln w="17780">
+          <a:ln w="25400">
             <a:solidFill>
-              <a:srgbClr val="888888"/>
+              <a:srgbClr val="596273"/>
             </a:solidFill>
             <a:prstDash val="solid"/>
-            <a:headEnd type="triangle"/>
-            <a:tailEnd type="triangle"/>
+            <a:headEnd type="triangle" w="lg" len="lg"/>
+            <a:tailEnd type="triangle" w="lg" len="lg"/>
           </a:ln>
         </p:spPr>
       </p:sp>
@@ -11219,13 +11219,13 @@
             <a:avLst/>
           </a:prstGeom>
           <a:noFill/>
-          <a:ln w="17780">
+          <a:ln w="25400">
             <a:solidFill>
-              <a:srgbClr val="AAAAAA"/>
+              <a:srgbClr val="596273"/>
             </a:solidFill>
             <a:prstDash val="dash"/>
             <a:headEnd type="none"/>
-            <a:tailEnd type="triangle"/>
+            <a:tailEnd type="triangle" w="lg" len="lg"/>
           </a:ln>
         </p:spPr>
       </p:sp>
@@ -11244,13 +11244,13 @@
             <a:avLst/>
           </a:prstGeom>
           <a:noFill/>
-          <a:ln w="17780">
+          <a:ln w="25400">
             <a:solidFill>
-              <a:srgbClr val="AAAAAA"/>
+              <a:srgbClr val="596273"/>
             </a:solidFill>
             <a:prstDash val="dash"/>
             <a:headEnd type="none"/>
-            <a:tailEnd type="triangle"/>
+            <a:tailEnd type="triangle" w="lg" len="lg"/>
           </a:ln>
         </p:spPr>
       </p:sp>
@@ -11269,13 +11269,13 @@
             <a:avLst/>
           </a:prstGeom>
           <a:noFill/>
-          <a:ln w="17780">
+          <a:ln w="25400">
             <a:solidFill>
-              <a:srgbClr val="AAAAAA"/>
+              <a:srgbClr val="596273"/>
             </a:solidFill>
             <a:prstDash val="dash"/>
             <a:headEnd type="none"/>
-            <a:tailEnd type="triangle"/>
+            <a:tailEnd type="triangle" w="lg" len="lg"/>
           </a:ln>
         </p:spPr>
       </p:sp>
@@ -11294,13 +11294,13 @@
             <a:avLst/>
           </a:prstGeom>
           <a:noFill/>
-          <a:ln w="17780">
+          <a:ln w="25400">
             <a:solidFill>
-              <a:srgbClr val="AAAAAA"/>
+              <a:srgbClr val="596273"/>
             </a:solidFill>
             <a:prstDash val="dash"/>
             <a:headEnd type="none"/>
-            <a:tailEnd type="triangle"/>
+            <a:tailEnd type="triangle" w="lg" len="lg"/>
           </a:ln>
         </p:spPr>
       </p:sp>
@@ -20762,7 +20762,7 @@
 </file>
 
 <file path=ppt/slides/slide3.xml><?xml version="1.0" encoding="utf-8"?>
-<p:sld xmlns:a="http://schemas.openxmlformats.org/drawingml/2006/main" xmlns:r="http://schemas.openxmlformats.org/officeDocument/2006/relationships" xmlns:p="http://schemas.openxmlformats.org/presentationml/2006/main">
+<p:sld xmlns:a="http://schemas.openxmlformats.org/drawingml/2006/main" xmlns:p="http://schemas.openxmlformats.org/presentationml/2006/main">
   <p:cSld name="Slide 3">
     <p:bg>
       <p:bgPr>
@@ -20938,7 +20938,7 @@
                 <a:ea typeface="Calibri" pitchFamily="34" charset="-122"/>
                 <a:cs typeface="Calibri" pitchFamily="34" charset="-120"/>
               </a:rPr>
-              <a:t>The 30,000-ft view</a:t>
+              <a:t>Layered platform view</a:t>
             </a:r>
             <a:endParaRPr lang="en-US" sz="1050" dirty="0"/>
           </a:p>
@@ -21609,7 +21609,7 @@
                 <a:ea typeface="Calibri" pitchFamily="34" charset="-122"/>
                 <a:cs typeface="Calibri" pitchFamily="34" charset="-120"/>
               </a:rPr>
-              <a:t>This is the 30,000-ft view — each module diagram (4-7) zooms into one API layer service</a:t>
+              <a:t>Security and compliance controls apply across the presentation, API and data layers</a:t>
             </a:r>
             <a:endParaRPr lang="en-US" sz="900" dirty="0"/>
           </a:p>
@@ -21624,7 +21624,7 @@
 </file>
 
 <file path=ppt/slides/slide4.xml><?xml version="1.0" encoding="utf-8"?>
-<p:sld xmlns:a="http://schemas.openxmlformats.org/drawingml/2006/main" xmlns:r="http://schemas.openxmlformats.org/officeDocument/2006/relationships" xmlns:p="http://schemas.openxmlformats.org/presentationml/2006/main">
+<p:sld xmlns:a="http://schemas.openxmlformats.org/drawingml/2006/main" xmlns:p="http://schemas.openxmlformats.org/presentationml/2006/main">
   <p:cSld name="Slide 4">
     <p:bg>
       <p:bgPr>
@@ -21800,7 +21800,7 @@
                 <a:ea typeface="Calibri" pitchFamily="34" charset="-122"/>
                 <a:cs typeface="Calibri" pitchFamily="34" charset="-120"/>
               </a:rPr>
-              <a:t>Composite reference — each module is fully detailed in diagrams 4-8</a:t>
+              <a:t>Five implementation modules and their primary responsibilities</a:t>
             </a:r>
             <a:endParaRPr lang="en-US" sz="1050" dirty="0"/>
           </a:p>
@@ -22753,7 +22753,7 @@
                 <a:ea typeface="Calibri" pitchFamily="34" charset="-122"/>
                 <a:cs typeface="Calibri" pitchFamily="34" charset="-120"/>
               </a:rPr>
-              <a:t>This slide exists to index the detail, not duplicate it — see diagrams 4-8 for full architecture, framework badges, and data model per module</a:t>
+              <a:t>Each module follows the shared React, FastAPI and PostgreSQL architecture with common security, audit and reporting controls</a:t>
             </a:r>
             <a:endParaRPr lang="en-US" sz="900" dirty="0"/>
           </a:p>
@@ -22768,7 +22768,7 @@
 </file>
 
 <file path=ppt/slides/slide5.xml><?xml version="1.0" encoding="utf-8"?>
-<p:sld xmlns:a="http://schemas.openxmlformats.org/drawingml/2006/main" xmlns:r="http://schemas.openxmlformats.org/officeDocument/2006/relationships" xmlns:p="http://schemas.openxmlformats.org/presentationml/2006/main">
+<p:sld xmlns:a="http://schemas.openxmlformats.org/drawingml/2006/main" xmlns:p="http://schemas.openxmlformats.org/presentationml/2006/main">
   <p:cSld name="Slide 5">
     <p:bg>
       <p:bgPr>
@@ -24997,7 +24997,7 @@
                 <a:ea typeface="Calibri" pitchFamily="34" charset="-122"/>
                 <a:cs typeface="Calibri" pitchFamily="34" charset="-120"/>
               </a:rPr>
-              <a:t>Writes directly into PostgreSQL — see diagram 1 for the full enterprise data-flow context</a:t>
+              <a:t>Wallet and identity operations write directly to PostgreSQL</a:t>
             </a:r>
             <a:endParaRPr lang="en-US" sz="900" dirty="0"/>
           </a:p>
@@ -27256,7 +27256,7 @@
 </file>
 
 <file path=ppt/slides/slide7.xml><?xml version="1.0" encoding="utf-8"?>
-<p:sld xmlns:a="http://schemas.openxmlformats.org/drawingml/2006/main" xmlns:r="http://schemas.openxmlformats.org/officeDocument/2006/relationships" xmlns:p="http://schemas.openxmlformats.org/presentationml/2006/main">
+<p:sld xmlns:a="http://schemas.openxmlformats.org/drawingml/2006/main" xmlns:p="http://schemas.openxmlformats.org/presentationml/2006/main">
   <p:cSld name="Slide 7">
     <p:bg>
       <p:bgPr>
@@ -29485,7 +29485,7 @@
                 <a:ea typeface="Calibri" pitchFamily="34" charset="-122"/>
                 <a:cs typeface="Calibri" pitchFamily="34" charset="-120"/>
               </a:rPr>
-              <a:t>PIS calls Module 2's transfer logic directly rather than duplicating it — see diagram 8 for CBDC's separate ledger</a:t>
+              <a:t>PIS reuses Module 2 transfer logic; CBDC wallet and operation records remain separate from commercial wallets</a:t>
             </a:r>
             <a:endParaRPr lang="en-US" sz="900" dirty="0"/>
           </a:p>

</xml_diff>

<commit_message>
Refine DFD connector styling and routing
</commit_message>
<xml_diff>
--- a/docs/architecture/GlobalPay_Mandatory_Architecture_Deliverables.pptx
+++ b/docs/architecture/GlobalPay_Mandatory_Architecture_Deliverables.pptx
@@ -9445,19 +9445,19 @@
         <p:spPr>
           <a:xfrm>
             <a:off x="1874520" y="1600200"/>
-            <a:ext cx="5596128" cy="2377440"/>
+            <a:ext cx="3277000" cy="1150000"/>
           </a:xfrm>
           <a:prstGeom prst="line">
             <a:avLst/>
           </a:prstGeom>
           <a:noFill/>
-          <a:ln w="25400">
+          <a:ln w="17780">
             <a:solidFill>
-              <a:srgbClr val="4B5563"/>
+              <a:srgbClr val="858F9E"/>
             </a:solidFill>
             <a:prstDash val="solid"/>
-            <a:headEnd type="triangle" w="lg" len="lg"/>
-            <a:tailEnd type="triangle" w="lg" len="lg"/>
+            <a:headEnd type="triangle" w="med" len="med"/>
+            <a:tailEnd type="triangle" w="med" len="med"/>
           </a:ln>
         </p:spPr>
       </p:sp>
@@ -9469,20 +9469,20 @@
         </p:nvSpPr>
         <p:spPr>
           <a:xfrm flipH="1">
-            <a:off x="4727448" y="1600200"/>
-            <a:ext cx="5559552" cy="2377440"/>
+            <a:off x="7050000" y="1600200"/>
+            <a:ext cx="3236000" cy="1150000"/>
           </a:xfrm>
           <a:prstGeom prst="line">
             <a:avLst/>
           </a:prstGeom>
           <a:noFill/>
-          <a:ln w="25400">
+          <a:ln w="17780">
             <a:solidFill>
-              <a:srgbClr val="4B5563"/>
+              <a:srgbClr val="858F9E"/>
             </a:solidFill>
             <a:prstDash val="solid"/>
-            <a:headEnd type="triangle" w="lg" len="lg"/>
-            <a:tailEnd type="triangle" w="lg" len="lg"/>
+            <a:headEnd type="triangle" w="med" len="med"/>
+            <a:tailEnd type="triangle" w="med" len="med"/>
           </a:ln>
         </p:spPr>
       </p:sp>
@@ -9494,20 +9494,20 @@
         </p:nvSpPr>
         <p:spPr>
           <a:xfrm flipV="1">
-            <a:off x="1874520" y="2514600"/>
-            <a:ext cx="5596128" cy="2194560"/>
+            <a:off x="1874520" y="3740000"/>
+            <a:ext cx="3277000" cy="969160"/>
           </a:xfrm>
           <a:prstGeom prst="line">
             <a:avLst/>
           </a:prstGeom>
           <a:noFill/>
-          <a:ln w="25400">
+          <a:ln w="17780">
             <a:solidFill>
-              <a:srgbClr val="4B5563"/>
+              <a:srgbClr val="858F9E"/>
             </a:solidFill>
             <a:prstDash val="solid"/>
-            <a:headEnd type="triangle" w="lg" len="lg"/>
-            <a:tailEnd type="triangle" w="lg" len="lg"/>
+            <a:headEnd type="triangle" w="med" len="med"/>
+            <a:tailEnd type="triangle" w="med" len="med"/>
           </a:ln>
         </p:spPr>
       </p:sp>
@@ -9519,20 +9519,20 @@
         </p:nvSpPr>
         <p:spPr>
           <a:xfrm flipH="1" flipV="1">
-            <a:off x="4727448" y="2514600"/>
-            <a:ext cx="5559552" cy="2194560"/>
+            <a:off x="7050000" y="3740000"/>
+            <a:ext cx="3236000" cy="969160"/>
           </a:xfrm>
           <a:prstGeom prst="line">
             <a:avLst/>
           </a:prstGeom>
           <a:noFill/>
-          <a:ln w="25400">
+          <a:ln w="17780">
             <a:solidFill>
-              <a:srgbClr val="4B5563"/>
+              <a:srgbClr val="858F9E"/>
             </a:solidFill>
             <a:prstDash val="solid"/>
-            <a:headEnd type="triangle" w="lg" len="lg"/>
-            <a:tailEnd type="triangle" w="lg" len="lg"/>
+            <a:headEnd type="triangle" w="med" len="med"/>
+            <a:tailEnd type="triangle" w="med" len="med"/>
           </a:ln>
         </p:spPr>
       </p:sp>
@@ -9544,20 +9544,20 @@
         </p:nvSpPr>
         <p:spPr>
           <a:xfrm flipV="1">
-            <a:off x="6053328" y="2514600"/>
-            <a:ext cx="1417320" cy="2514600"/>
+            <a:off x="6048756" y="3977640"/>
+            <a:ext cx="9144" cy="1051560"/>
           </a:xfrm>
           <a:prstGeom prst="line">
             <a:avLst/>
           </a:prstGeom>
           <a:noFill/>
-          <a:ln w="25400">
+          <a:ln w="17780">
             <a:solidFill>
-              <a:srgbClr val="4B5563"/>
+              <a:srgbClr val="858F9E"/>
             </a:solidFill>
             <a:prstDash val="solid"/>
-            <a:headEnd type="triangle" w="lg" len="lg"/>
-            <a:tailEnd type="triangle" w="lg" len="lg"/>
+            <a:headEnd type="triangle" w="med" len="med"/>
+            <a:tailEnd type="triangle" w="med" len="med"/>
           </a:ln>
         </p:spPr>
       </p:sp>
@@ -10524,13 +10524,13 @@
             <a:avLst/>
           </a:prstGeom>
           <a:noFill/>
-          <a:ln w="25400">
+          <a:ln w="17780">
             <a:solidFill>
-              <a:srgbClr val="596273"/>
+              <a:srgbClr val="858F9E"/>
             </a:solidFill>
             <a:prstDash val="solid"/>
             <a:headEnd type="none"/>
-            <a:tailEnd type="triangle" w="lg" len="lg"/>
+            <a:tailEnd type="triangle" w="med" len="med"/>
           </a:ln>
         </p:spPr>
       </p:sp>
@@ -10630,13 +10630,13 @@
             <a:avLst/>
           </a:prstGeom>
           <a:noFill/>
-          <a:ln w="25400">
+          <a:ln w="17780">
             <a:solidFill>
-              <a:srgbClr val="596273"/>
+              <a:srgbClr val="858F9E"/>
             </a:solidFill>
             <a:prstDash val="solid"/>
             <a:headEnd type="none"/>
-            <a:tailEnd type="triangle" w="lg" len="lg"/>
+            <a:tailEnd type="triangle" w="med" len="med"/>
           </a:ln>
         </p:spPr>
       </p:sp>
@@ -10736,13 +10736,13 @@
             <a:avLst/>
           </a:prstGeom>
           <a:noFill/>
-          <a:ln w="25400">
+          <a:ln w="17780">
             <a:solidFill>
-              <a:srgbClr val="596273"/>
+              <a:srgbClr val="858F9E"/>
             </a:solidFill>
             <a:prstDash val="solid"/>
             <a:headEnd type="none"/>
-            <a:tailEnd type="triangle" w="lg" len="lg"/>
+            <a:tailEnd type="triangle" w="med" len="med"/>
           </a:ln>
         </p:spPr>
       </p:sp>
@@ -10842,13 +10842,13 @@
             <a:avLst/>
           </a:prstGeom>
           <a:noFill/>
-          <a:ln w="25400">
+          <a:ln w="17780">
             <a:solidFill>
-              <a:srgbClr val="596273"/>
+              <a:srgbClr val="858F9E"/>
             </a:solidFill>
             <a:prstDash val="solid"/>
             <a:headEnd type="none"/>
-            <a:tailEnd type="triangle" w="lg" len="lg"/>
+            <a:tailEnd type="triangle" w="med" len="med"/>
           </a:ln>
         </p:spPr>
       </p:sp>
@@ -10948,13 +10948,13 @@
             <a:avLst/>
           </a:prstGeom>
           <a:noFill/>
-          <a:ln w="25400">
+          <a:ln w="17780">
             <a:solidFill>
-              <a:srgbClr val="596273"/>
+              <a:srgbClr val="858F9E"/>
             </a:solidFill>
             <a:prstDash val="solid"/>
             <a:headEnd type="none"/>
-            <a:tailEnd type="triangle" w="lg" len="lg"/>
+            <a:tailEnd type="triangle" w="med" len="med"/>
           </a:ln>
         </p:spPr>
       </p:sp>
@@ -11039,13 +11039,13 @@
             <a:avLst/>
           </a:prstGeom>
           <a:noFill/>
-          <a:ln w="25400">
+          <a:ln w="17780">
             <a:solidFill>
-              <a:srgbClr val="596273"/>
+              <a:srgbClr val="858F9E"/>
             </a:solidFill>
             <a:prstDash val="solid"/>
             <a:headEnd type="none"/>
-            <a:tailEnd type="triangle" w="lg" len="lg"/>
+            <a:tailEnd type="triangle" w="med" len="med"/>
           </a:ln>
         </p:spPr>
       </p:sp>
@@ -11130,13 +11130,13 @@
             <a:avLst/>
           </a:prstGeom>
           <a:noFill/>
-          <a:ln w="25400">
+          <a:ln w="17780">
             <a:solidFill>
-              <a:srgbClr val="596273"/>
+              <a:srgbClr val="858F9E"/>
             </a:solidFill>
             <a:prstDash val="solid"/>
             <a:headEnd type="none"/>
-            <a:tailEnd type="triangle" w="lg" len="lg"/>
+            <a:tailEnd type="triangle" w="med" len="med"/>
           </a:ln>
         </p:spPr>
       </p:sp>
@@ -11155,13 +11155,13 @@
             <a:avLst/>
           </a:prstGeom>
           <a:noFill/>
-          <a:ln w="25400">
+          <a:ln w="17780">
             <a:solidFill>
-              <a:srgbClr val="596273"/>
+              <a:srgbClr val="858F9E"/>
             </a:solidFill>
             <a:prstDash val="solid"/>
-            <a:headEnd type="triangle" w="lg" len="lg"/>
-            <a:tailEnd type="triangle" w="lg" len="lg"/>
+            <a:headEnd type="triangle" w="med" len="med"/>
+            <a:tailEnd type="triangle" w="med" len="med"/>
           </a:ln>
         </p:spPr>
       </p:sp>
@@ -11219,13 +11219,13 @@
             <a:avLst/>
           </a:prstGeom>
           <a:noFill/>
-          <a:ln w="25400">
+          <a:ln w="17780">
             <a:solidFill>
-              <a:srgbClr val="596273"/>
+              <a:srgbClr val="B6BCC6"/>
             </a:solidFill>
-            <a:prstDash val="dash"/>
+            <a:prstDash val="dot"/>
             <a:headEnd type="none"/>
-            <a:tailEnd type="triangle" w="lg" len="lg"/>
+            <a:tailEnd type="triangle" w="med" len="med"/>
           </a:ln>
         </p:spPr>
       </p:sp>
@@ -11244,13 +11244,13 @@
             <a:avLst/>
           </a:prstGeom>
           <a:noFill/>
-          <a:ln w="25400">
+          <a:ln w="17780">
             <a:solidFill>
-              <a:srgbClr val="596273"/>
+              <a:srgbClr val="B6BCC6"/>
             </a:solidFill>
-            <a:prstDash val="dash"/>
+            <a:prstDash val="dot"/>
             <a:headEnd type="none"/>
-            <a:tailEnd type="triangle" w="lg" len="lg"/>
+            <a:tailEnd type="triangle" w="med" len="med"/>
           </a:ln>
         </p:spPr>
       </p:sp>
@@ -11269,13 +11269,13 @@
             <a:avLst/>
           </a:prstGeom>
           <a:noFill/>
-          <a:ln w="25400">
+          <a:ln w="17780">
             <a:solidFill>
-              <a:srgbClr val="596273"/>
+              <a:srgbClr val="B6BCC6"/>
             </a:solidFill>
-            <a:prstDash val="dash"/>
+            <a:prstDash val="dot"/>
             <a:headEnd type="none"/>
-            <a:tailEnd type="triangle" w="lg" len="lg"/>
+            <a:tailEnd type="triangle" w="med" len="med"/>
           </a:ln>
         </p:spPr>
       </p:sp>
@@ -11294,13 +11294,13 @@
             <a:avLst/>
           </a:prstGeom>
           <a:noFill/>
-          <a:ln w="25400">
+          <a:ln w="17780">
             <a:solidFill>
-              <a:srgbClr val="596273"/>
+              <a:srgbClr val="B6BCC6"/>
             </a:solidFill>
-            <a:prstDash val="dash"/>
+            <a:prstDash val="dot"/>
             <a:headEnd type="none"/>
-            <a:tailEnd type="triangle" w="lg" len="lg"/>
+            <a:tailEnd type="triangle" w="med" len="med"/>
           </a:ln>
         </p:spPr>
       </p:sp>

</xml_diff>